<commit_message>
docs(marketing): restyle investor pitch deck to expo design system
Rebuilds the deck on the expo marketing kit (Option A dark surfaces, Inter, one-accent rule) with the app's brand orange #FF6600 as the accent, and adds tour screenshots (schedule, tutors, library, league) as slide backgrounds on the solution, business-model, traction and go-to-market slides. Same content and figures; same file path so the grant-form link is unchanged.
</commit_message>
<xml_diff>
--- a/marketing/pitch/supacharge-pitch-deck.pptx
+++ b/marketing/pitch/supacharge-pitch-deck.pptx
@@ -54,7 +54,7 @@
     <p:bg>
       <p:bgPr>
         <a:solidFill>
-          <a:srgbClr val="F3F0E7"/>
+          <a:srgbClr val="0B0B0B"/>
         </a:solidFill>
         <a:effectLst/>
       </p:bgPr>
@@ -157,7 +157,7 @@
             <a:r>
               <a:rPr lang="en-US" sz="4000" b="1" i="0" dirty="0">
                 <a:solidFill>
-                  <a:srgbClr val="1F1F1F"/>
+                  <a:srgbClr val="FFFFFF"/>
                 </a:solidFill>
                 <a:latin typeface="Inter"/>
                 <a:cs typeface="Inter"/>
@@ -198,7 +198,7 @@
             <a:r>
               <a:rPr lang="en-US" sz="1800" b="0" i="0" dirty="0">
                 <a:solidFill>
-                  <a:srgbClr val="3A3A3A"/>
+                  <a:srgbClr val="9A9A9A"/>
                 </a:solidFill>
                 <a:latin typeface="Inter"/>
                 <a:cs typeface="Inter"/>
@@ -216,7 +216,7 @@
             <a:r>
               <a:rPr lang="en-US" sz="1500" b="0" i="0" dirty="0">
                 <a:solidFill>
-                  <a:srgbClr val="FBFAF6"/>
+                  <a:srgbClr val="5A5A5A"/>
                 </a:solidFill>
                 <a:latin typeface="Inter"/>
                 <a:cs typeface="Inter"/>
@@ -257,7 +257,7 @@
             <a:r>
               <a:rPr lang="en-US" sz="1000" b="0" i="0" dirty="0">
                 <a:solidFill>
-                  <a:srgbClr val="FBFAF6"/>
+                  <a:srgbClr val="5A5A5A"/>
                 </a:solidFill>
                 <a:latin typeface="Inter"/>
                 <a:cs typeface="Inter"/>
@@ -321,7 +321,7 @@
             <a:r>
               <a:rPr lang="en-US" sz="2800" b="1" i="0" dirty="0">
                 <a:solidFill>
-                  <a:srgbClr val="1F1F1F"/>
+                  <a:srgbClr val="FFFFFF"/>
                 </a:solidFill>
                 <a:latin typeface="Inter"/>
                 <a:cs typeface="Inter"/>
@@ -401,7 +401,7 @@
             <a:r>
               <a:rPr lang="en-US" sz="1500" b="0" i="0" dirty="0">
                 <a:solidFill>
-                  <a:srgbClr val="3A3A3A"/>
+                  <a:srgbClr val="9A9A9A"/>
                 </a:solidFill>
                 <a:latin typeface="Inter"/>
                 <a:cs typeface="Inter"/>
@@ -429,7 +429,7 @@
             <a:r>
               <a:rPr lang="en-US" sz="1500" b="0" i="0" dirty="0">
                 <a:solidFill>
-                  <a:srgbClr val="3A3A3A"/>
+                  <a:srgbClr val="9A9A9A"/>
                 </a:solidFill>
                 <a:latin typeface="Inter"/>
                 <a:cs typeface="Inter"/>
@@ -447,7 +447,7 @@
             <a:r>
               <a:rPr lang="en-US" sz="1500" b="1" i="0" dirty="0">
                 <a:solidFill>
-                  <a:srgbClr val="1F1F1F"/>
+                  <a:srgbClr val="FFFFFF"/>
                 </a:solidFill>
                 <a:latin typeface="Inter"/>
                 <a:cs typeface="Inter"/>
@@ -475,7 +475,7 @@
             <a:r>
               <a:rPr lang="en-US" sz="1500" b="0" i="0" dirty="0">
                 <a:solidFill>
-                  <a:srgbClr val="3A3A3A"/>
+                  <a:srgbClr val="9A9A9A"/>
                 </a:solidFill>
                 <a:latin typeface="Inter"/>
                 <a:cs typeface="Inter"/>
@@ -503,7 +503,7 @@
             <a:r>
               <a:rPr lang="en-US" sz="1500" b="0" i="0" dirty="0">
                 <a:solidFill>
-                  <a:srgbClr val="3A3A3A"/>
+                  <a:srgbClr val="9A9A9A"/>
                 </a:solidFill>
                 <a:latin typeface="Inter"/>
                 <a:cs typeface="Inter"/>
@@ -531,7 +531,7 @@
             <a:r>
               <a:rPr lang="en-US" sz="1500" b="0" i="0" dirty="0">
                 <a:solidFill>
-                  <a:srgbClr val="3A3A3A"/>
+                  <a:srgbClr val="9A9A9A"/>
                 </a:solidFill>
                 <a:latin typeface="Inter"/>
                 <a:cs typeface="Inter"/>
@@ -559,7 +559,7 @@
             <a:r>
               <a:rPr lang="en-US" sz="1500" b="0" i="0" dirty="0">
                 <a:solidFill>
-                  <a:srgbClr val="3A3A3A"/>
+                  <a:srgbClr val="9A9A9A"/>
                 </a:solidFill>
                 <a:latin typeface="Inter"/>
                 <a:cs typeface="Inter"/>
@@ -600,7 +600,7 @@
             <a:r>
               <a:rPr lang="en-US" sz="1000" b="0" i="0" dirty="0">
                 <a:solidFill>
-                  <a:srgbClr val="FBFAF6"/>
+                  <a:srgbClr val="5A5A5A"/>
                 </a:solidFill>
                 <a:latin typeface="Inter"/>
                 <a:cs typeface="Inter"/>
@@ -664,7 +664,7 @@
             <a:r>
               <a:rPr lang="en-US" sz="2800" b="1" i="0" dirty="0">
                 <a:solidFill>
-                  <a:srgbClr val="1F1F1F"/>
+                  <a:srgbClr val="FFFFFF"/>
                 </a:solidFill>
                 <a:latin typeface="Inter"/>
                 <a:cs typeface="Inter"/>
@@ -734,7 +734,7 @@
             <a:r>
               <a:rPr lang="en-US" sz="1500" b="0" i="0" dirty="0">
                 <a:solidFill>
-                  <a:srgbClr val="3A3A3A"/>
+                  <a:srgbClr val="9A9A9A"/>
                 </a:solidFill>
                 <a:latin typeface="Inter"/>
                 <a:cs typeface="Inter"/>
@@ -752,7 +752,7 @@
             <a:r>
               <a:rPr lang="en-US" sz="1500" b="1" i="0" dirty="0">
                 <a:solidFill>
-                  <a:srgbClr val="1F1F1F"/>
+                  <a:srgbClr val="FFFFFF"/>
                 </a:solidFill>
                 <a:latin typeface="Inter"/>
                 <a:cs typeface="Inter"/>
@@ -780,7 +780,7 @@
             <a:r>
               <a:rPr lang="en-US" sz="1500" b="0" i="0" dirty="0">
                 <a:solidFill>
-                  <a:srgbClr val="3A3A3A"/>
+                  <a:srgbClr val="9A9A9A"/>
                 </a:solidFill>
                 <a:latin typeface="Inter"/>
                 <a:cs typeface="Inter"/>
@@ -808,7 +808,7 @@
             <a:r>
               <a:rPr lang="en-US" sz="1500" b="0" i="0" dirty="0">
                 <a:solidFill>
-                  <a:srgbClr val="3A3A3A"/>
+                  <a:srgbClr val="9A9A9A"/>
                 </a:solidFill>
                 <a:latin typeface="Inter"/>
                 <a:cs typeface="Inter"/>
@@ -849,7 +849,7 @@
             <a:r>
               <a:rPr lang="en-US" sz="1000" b="0" i="0" dirty="0">
                 <a:solidFill>
-                  <a:srgbClr val="FBFAF6"/>
+                  <a:srgbClr val="5A5A5A"/>
                 </a:solidFill>
                 <a:latin typeface="Inter"/>
                 <a:cs typeface="Inter"/>
@@ -913,7 +913,7 @@
             <a:r>
               <a:rPr lang="en-US" sz="2800" b="1" i="0" dirty="0">
                 <a:solidFill>
-                  <a:srgbClr val="1F1F1F"/>
+                  <a:srgbClr val="FFFFFF"/>
                 </a:solidFill>
                 <a:latin typeface="Inter"/>
                 <a:cs typeface="Inter"/>
@@ -993,7 +993,7 @@
             <a:r>
               <a:rPr lang="en-US" sz="1500" b="0" i="0" dirty="0">
                 <a:solidFill>
-                  <a:srgbClr val="3A3A3A"/>
+                  <a:srgbClr val="9A9A9A"/>
                 </a:solidFill>
                 <a:latin typeface="Inter"/>
                 <a:cs typeface="Inter"/>
@@ -1021,7 +1021,7 @@
             <a:r>
               <a:rPr lang="en-US" sz="1500" b="0" i="0" dirty="0">
                 <a:solidFill>
-                  <a:srgbClr val="3A3A3A"/>
+                  <a:srgbClr val="9A9A9A"/>
                 </a:solidFill>
                 <a:latin typeface="Inter"/>
                 <a:cs typeface="Inter"/>
@@ -1049,7 +1049,7 @@
             <a:r>
               <a:rPr lang="en-US" sz="1500" b="0" i="0" dirty="0">
                 <a:solidFill>
-                  <a:srgbClr val="3A3A3A"/>
+                  <a:srgbClr val="9A9A9A"/>
                 </a:solidFill>
                 <a:latin typeface="Inter"/>
                 <a:cs typeface="Inter"/>
@@ -1077,7 +1077,7 @@
             <a:r>
               <a:rPr lang="en-US" sz="1500" b="0" i="0" dirty="0">
                 <a:solidFill>
-                  <a:srgbClr val="3A3A3A"/>
+                  <a:srgbClr val="9A9A9A"/>
                 </a:solidFill>
                 <a:latin typeface="Inter"/>
                 <a:cs typeface="Inter"/>
@@ -1095,7 +1095,7 @@
             <a:r>
               <a:rPr lang="en-US" sz="1500" b="1" i="0" dirty="0">
                 <a:solidFill>
-                  <a:srgbClr val="1F1F1F"/>
+                  <a:srgbClr val="FFFFFF"/>
                 </a:solidFill>
                 <a:latin typeface="Inter"/>
                 <a:cs typeface="Inter"/>
@@ -1113,7 +1113,7 @@
             <a:r>
               <a:rPr lang="en-US" sz="1500" b="0" i="0" dirty="0">
                 <a:solidFill>
-                  <a:srgbClr val="3A3A3A"/>
+                  <a:srgbClr val="9A9A9A"/>
                 </a:solidFill>
                 <a:latin typeface="Inter"/>
                 <a:cs typeface="Inter"/>
@@ -1131,7 +1131,7 @@
             <a:r>
               <a:rPr lang="en-US" sz="1500" b="0" i="1" dirty="0">
                 <a:solidFill>
-                  <a:srgbClr val="FBFAF6"/>
+                  <a:srgbClr val="5A5A5A"/>
                 </a:solidFill>
                 <a:latin typeface="Inter"/>
                 <a:cs typeface="Inter"/>
@@ -1172,7 +1172,7 @@
             <a:r>
               <a:rPr lang="en-US" sz="1000" b="0" i="0" dirty="0">
                 <a:solidFill>
-                  <a:srgbClr val="FBFAF6"/>
+                  <a:srgbClr val="5A5A5A"/>
                 </a:solidFill>
                 <a:latin typeface="Inter"/>
                 <a:cs typeface="Inter"/>
@@ -1236,7 +1236,7 @@
             <a:r>
               <a:rPr lang="en-US" sz="2800" b="1" i="0" dirty="0">
                 <a:solidFill>
-                  <a:srgbClr val="1F1F1F"/>
+                  <a:srgbClr val="FFFFFF"/>
                 </a:solidFill>
                 <a:latin typeface="Inter"/>
                 <a:cs typeface="Inter"/>
@@ -1306,7 +1306,7 @@
             <a:r>
               <a:rPr lang="en-US" sz="1500" b="0" i="0" dirty="0">
                 <a:solidFill>
-                  <a:srgbClr val="3A3A3A"/>
+                  <a:srgbClr val="9A9A9A"/>
                 </a:solidFill>
                 <a:latin typeface="Inter"/>
                 <a:cs typeface="Inter"/>
@@ -1347,7 +1347,7 @@
             <a:r>
               <a:rPr lang="en-US" sz="1000" b="0" i="0" dirty="0">
                 <a:solidFill>
-                  <a:srgbClr val="FBFAF6"/>
+                  <a:srgbClr val="5A5A5A"/>
                 </a:solidFill>
                 <a:latin typeface="Inter"/>
                 <a:cs typeface="Inter"/>
@@ -1368,6 +1368,17 @@
 <file path=ppt/slides/slide3.xml><?xml version="1.0" encoding="utf-8"?>
 <p:sld xmlns:a="http://schemas.openxmlformats.org/drawingml/2006/main" xmlns:r="http://schemas.openxmlformats.org/officeDocument/2006/relationships" xmlns:p="http://schemas.openxmlformats.org/presentationml/2006/main">
   <p:cSld>
+    <p:bg>
+      <p:bgPr>
+        <a:blipFill>
+          <a:blip r:embed="rId2"/>
+          <a:stretch>
+            <a:fillRect/>
+          </a:stretch>
+        </a:blipFill>
+        <a:effectLst/>
+      </p:bgPr>
+    </p:bg>
     <p:spTree>
       <p:nvGrpSpPr>
         <p:cNvPr id="1" name=""/>
@@ -1384,7 +1395,38 @@
       </p:grpSpPr>
       <p:sp>
         <p:nvSpPr>
-          <p:cNvPr id="2" name="Title"/>
+          <p:cNvPr id="2" name="Scrim"/>
+          <p:cNvSpPr/>
+          <p:nvPr/>
+        </p:nvSpPr>
+        <p:spPr>
+          <a:xfrm>
+            <a:off x="0" y="0"/>
+            <a:ext cx="12192000" cy="6858000"/>
+          </a:xfrm>
+          <a:prstGeom prst="rect">
+            <a:avLst/>
+          </a:prstGeom>
+          <a:solidFill>
+            <a:srgbClr val="0B0B0B">
+              <a:alpha val="60000"/>
+            </a:srgbClr>
+          </a:solidFill>
+          <a:ln>
+            <a:noFill/>
+          </a:ln>
+        </p:spPr>
+        <p:txBody>
+          <a:bodyPr/>
+          <a:lstStyle/>
+          <a:p>
+            <a:endParaRPr lang="en-US"/>
+          </a:p>
+        </p:txBody>
+      </p:sp>
+      <p:sp>
+        <p:nvSpPr>
+          <p:cNvPr id="3" name="Title"/>
           <p:cNvSpPr txBox="1"/>
           <p:nvPr/>
         </p:nvSpPr>
@@ -1411,7 +1453,7 @@
             <a:r>
               <a:rPr lang="en-US" sz="2800" b="1" i="0" dirty="0">
                 <a:solidFill>
-                  <a:srgbClr val="1F1F1F"/>
+                  <a:srgbClr val="FFFFFF"/>
                 </a:solidFill>
                 <a:latin typeface="Inter"/>
                 <a:cs typeface="Inter"/>
@@ -1423,7 +1465,7 @@
       </p:sp>
       <p:sp>
         <p:nvSpPr>
-          <p:cNvPr id="3" name="Accent"/>
+          <p:cNvPr id="4" name="Accent"/>
           <p:cNvSpPr/>
           <p:nvPr/>
         </p:nvSpPr>
@@ -1452,7 +1494,7 @@
       </p:sp>
       <p:sp>
         <p:nvSpPr>
-          <p:cNvPr id="4" name="Body"/>
+          <p:cNvPr id="5" name="Body"/>
           <p:cNvSpPr txBox="1"/>
           <p:nvPr/>
         </p:nvSpPr>
@@ -1481,7 +1523,7 @@
             <a:r>
               <a:rPr lang="en-US" sz="1500" b="0" i="0" dirty="0">
                 <a:solidFill>
-                  <a:srgbClr val="3A3A3A"/>
+                  <a:srgbClr val="9A9A9A"/>
                 </a:solidFill>
                 <a:latin typeface="Inter"/>
                 <a:cs typeface="Inter"/>
@@ -1499,7 +1541,7 @@
             <a:r>
               <a:rPr lang="en-US" sz="1500" b="1" i="0" dirty="0">
                 <a:solidFill>
-                  <a:srgbClr val="1F1F1F"/>
+                  <a:srgbClr val="FFFFFF"/>
                 </a:solidFill>
                 <a:latin typeface="Inter"/>
                 <a:cs typeface="Inter"/>
@@ -1517,7 +1559,7 @@
             <a:r>
               <a:rPr lang="en-US" sz="1500" b="0" i="0" dirty="0">
                 <a:solidFill>
-                  <a:srgbClr val="3A3A3A"/>
+                  <a:srgbClr val="9A9A9A"/>
                 </a:solidFill>
                 <a:latin typeface="Inter"/>
                 <a:cs typeface="Inter"/>
@@ -1529,7 +1571,7 @@
       </p:sp>
       <p:sp>
         <p:nvSpPr>
-          <p:cNvPr id="5" name="Footer"/>
+          <p:cNvPr id="6" name="Footer"/>
           <p:cNvSpPr txBox="1"/>
           <p:nvPr/>
         </p:nvSpPr>
@@ -1558,7 +1600,7 @@
             <a:r>
               <a:rPr lang="en-US" sz="1000" b="0" i="0" dirty="0">
                 <a:solidFill>
-                  <a:srgbClr val="FBFAF6"/>
+                  <a:srgbClr val="5A5A5A"/>
                 </a:solidFill>
                 <a:latin typeface="Inter"/>
                 <a:cs typeface="Inter"/>
@@ -1622,7 +1664,7 @@
             <a:r>
               <a:rPr lang="en-US" sz="2800" b="1" i="0" dirty="0">
                 <a:solidFill>
-                  <a:srgbClr val="1F1F1F"/>
+                  <a:srgbClr val="FFFFFF"/>
                 </a:solidFill>
                 <a:latin typeface="Inter"/>
                 <a:cs typeface="Inter"/>
@@ -1695,7 +1737,7 @@
                       <a:r>
                         <a:rPr lang="en-US" sz="1200" b="1" i="0" dirty="0">
                           <a:solidFill>
-                            <a:srgbClr val="1F1F1F"/>
+                            <a:srgbClr val="2A1204"/>
                           </a:solidFill>
                           <a:latin typeface="Inter"/>
                           <a:cs typeface="Inter"/>
@@ -1724,7 +1766,7 @@
                       <a:r>
                         <a:rPr lang="en-US" sz="1200" b="1" i="0" dirty="0">
                           <a:solidFill>
-                            <a:srgbClr val="1F1F1F"/>
+                            <a:srgbClr val="2A1204"/>
                           </a:solidFill>
                           <a:latin typeface="Inter"/>
                           <a:cs typeface="Inter"/>
@@ -1753,7 +1795,7 @@
                       <a:r>
                         <a:rPr lang="en-US" sz="1200" b="1" i="0" dirty="0">
                           <a:solidFill>
-                            <a:srgbClr val="1F1F1F"/>
+                            <a:srgbClr val="2A1204"/>
                           </a:solidFill>
                           <a:latin typeface="Inter"/>
                           <a:cs typeface="Inter"/>
@@ -1784,7 +1826,7 @@
                       <a:r>
                         <a:rPr lang="en-US" sz="1200" b="0" i="0" dirty="0">
                           <a:solidFill>
-                            <a:srgbClr val="3A3A3A"/>
+                            <a:srgbClr val="9A9A9A"/>
                           </a:solidFill>
                           <a:latin typeface="Inter"/>
                           <a:cs typeface="Inter"/>
@@ -1809,7 +1851,7 @@
                       <a:r>
                         <a:rPr lang="en-US" sz="1200" b="0" i="0" dirty="0">
                           <a:solidFill>
-                            <a:srgbClr val="3A3A3A"/>
+                            <a:srgbClr val="9A9A9A"/>
                           </a:solidFill>
                           <a:latin typeface="Inter"/>
                           <a:cs typeface="Inter"/>
@@ -1834,7 +1876,7 @@
                       <a:r>
                         <a:rPr lang="en-US" sz="1200" b="0" i="0" dirty="0">
                           <a:solidFill>
-                            <a:srgbClr val="3A3A3A"/>
+                            <a:srgbClr val="9A9A9A"/>
                           </a:solidFill>
                           <a:latin typeface="Inter"/>
                           <a:cs typeface="Inter"/>
@@ -1861,7 +1903,7 @@
                       <a:r>
                         <a:rPr lang="en-US" sz="1200" b="0" i="0" dirty="0">
                           <a:solidFill>
-                            <a:srgbClr val="3A3A3A"/>
+                            <a:srgbClr val="9A9A9A"/>
                           </a:solidFill>
                           <a:latin typeface="Inter"/>
                           <a:cs typeface="Inter"/>
@@ -1872,7 +1914,7 @@
                   </a:txBody>
                   <a:tcPr marL="91440" marR="91440" marT="45720" marB="45720">
                     <a:solidFill>
-                      <a:srgbClr val="FBFAF6"/>
+                      <a:srgbClr val="161616"/>
                     </a:solidFill>
                   </a:tcPr>
                 </a:tc>
@@ -1890,7 +1932,7 @@
                       <a:r>
                         <a:rPr lang="en-US" sz="1200" b="0" i="0" dirty="0">
                           <a:solidFill>
-                            <a:srgbClr val="3A3A3A"/>
+                            <a:srgbClr val="9A9A9A"/>
                           </a:solidFill>
                           <a:latin typeface="Inter"/>
                           <a:cs typeface="Inter"/>
@@ -1901,7 +1943,7 @@
                   </a:txBody>
                   <a:tcPr marL="91440" marR="91440" marT="45720" marB="45720">
                     <a:solidFill>
-                      <a:srgbClr val="FBFAF6"/>
+                      <a:srgbClr val="161616"/>
                     </a:solidFill>
                   </a:tcPr>
                 </a:tc>
@@ -1919,7 +1961,7 @@
                       <a:r>
                         <a:rPr lang="en-US" sz="1200" b="0" i="0" dirty="0">
                           <a:solidFill>
-                            <a:srgbClr val="3A3A3A"/>
+                            <a:srgbClr val="9A9A9A"/>
                           </a:solidFill>
                           <a:latin typeface="Inter"/>
                           <a:cs typeface="Inter"/>
@@ -1930,7 +1972,7 @@
                   </a:txBody>
                   <a:tcPr marL="91440" marR="91440" marT="45720" marB="45720">
                     <a:solidFill>
-                      <a:srgbClr val="FBFAF6"/>
+                      <a:srgbClr val="161616"/>
                     </a:solidFill>
                   </a:tcPr>
                 </a:tc>
@@ -1950,7 +1992,7 @@
                       <a:r>
                         <a:rPr lang="en-US" sz="1200" b="0" i="0" dirty="0">
                           <a:solidFill>
-                            <a:srgbClr val="3A3A3A"/>
+                            <a:srgbClr val="9A9A9A"/>
                           </a:solidFill>
                           <a:latin typeface="Inter"/>
                           <a:cs typeface="Inter"/>
@@ -1975,7 +2017,7 @@
                       <a:r>
                         <a:rPr lang="en-US" sz="1200" b="0" i="0" dirty="0">
                           <a:solidFill>
-                            <a:srgbClr val="3A3A3A"/>
+                            <a:srgbClr val="9A9A9A"/>
                           </a:solidFill>
                           <a:latin typeface="Inter"/>
                           <a:cs typeface="Inter"/>
@@ -2000,7 +2042,7 @@
                       <a:r>
                         <a:rPr lang="en-US" sz="1200" b="0" i="0" dirty="0">
                           <a:solidFill>
-                            <a:srgbClr val="3A3A3A"/>
+                            <a:srgbClr val="9A9A9A"/>
                           </a:solidFill>
                           <a:latin typeface="Inter"/>
                           <a:cs typeface="Inter"/>
@@ -2047,7 +2089,7 @@
             <a:r>
               <a:rPr lang="en-US" sz="1500" b="1" i="0" dirty="0">
                 <a:solidFill>
-                  <a:srgbClr val="1F1F1F"/>
+                  <a:srgbClr val="FFFFFF"/>
                 </a:solidFill>
                 <a:latin typeface="Inter"/>
                 <a:cs typeface="Inter"/>
@@ -2065,7 +2107,7 @@
             <a:r>
               <a:rPr lang="en-US" sz="1500" b="0" i="0" dirty="0">
                 <a:solidFill>
-                  <a:srgbClr val="3A3A3A"/>
+                  <a:srgbClr val="9A9A9A"/>
                 </a:solidFill>
                 <a:latin typeface="Inter"/>
                 <a:cs typeface="Inter"/>
@@ -2106,7 +2148,7 @@
             <a:r>
               <a:rPr lang="en-US" sz="1000" b="0" i="0" dirty="0">
                 <a:solidFill>
-                  <a:srgbClr val="FBFAF6"/>
+                  <a:srgbClr val="5A5A5A"/>
                 </a:solidFill>
                 <a:latin typeface="Inter"/>
                 <a:cs typeface="Inter"/>
@@ -2127,6 +2169,17 @@
 <file path=ppt/slides/slide5.xml><?xml version="1.0" encoding="utf-8"?>
 <p:sld xmlns:a="http://schemas.openxmlformats.org/drawingml/2006/main" xmlns:r="http://schemas.openxmlformats.org/officeDocument/2006/relationships" xmlns:p="http://schemas.openxmlformats.org/presentationml/2006/main">
   <p:cSld>
+    <p:bg>
+      <p:bgPr>
+        <a:blipFill>
+          <a:blip r:embed="rId2"/>
+          <a:stretch>
+            <a:fillRect/>
+          </a:stretch>
+        </a:blipFill>
+        <a:effectLst/>
+      </p:bgPr>
+    </p:bg>
     <p:spTree>
       <p:nvGrpSpPr>
         <p:cNvPr id="1" name=""/>
@@ -2143,7 +2196,38 @@
       </p:grpSpPr>
       <p:sp>
         <p:nvSpPr>
-          <p:cNvPr id="2" name="Title"/>
+          <p:cNvPr id="2" name="Scrim"/>
+          <p:cNvSpPr/>
+          <p:nvPr/>
+        </p:nvSpPr>
+        <p:spPr>
+          <a:xfrm>
+            <a:off x="0" y="0"/>
+            <a:ext cx="12192000" cy="6858000"/>
+          </a:xfrm>
+          <a:prstGeom prst="rect">
+            <a:avLst/>
+          </a:prstGeom>
+          <a:solidFill>
+            <a:srgbClr val="0B0B0B">
+              <a:alpha val="60000"/>
+            </a:srgbClr>
+          </a:solidFill>
+          <a:ln>
+            <a:noFill/>
+          </a:ln>
+        </p:spPr>
+        <p:txBody>
+          <a:bodyPr/>
+          <a:lstStyle/>
+          <a:p>
+            <a:endParaRPr lang="en-US"/>
+          </a:p>
+        </p:txBody>
+      </p:sp>
+      <p:sp>
+        <p:nvSpPr>
+          <p:cNvPr id="3" name="Title"/>
           <p:cNvSpPr txBox="1"/>
           <p:nvPr/>
         </p:nvSpPr>
@@ -2170,7 +2254,7 @@
             <a:r>
               <a:rPr lang="en-US" sz="2800" b="1" i="0" dirty="0">
                 <a:solidFill>
-                  <a:srgbClr val="1F1F1F"/>
+                  <a:srgbClr val="FFFFFF"/>
                 </a:solidFill>
                 <a:latin typeface="Inter"/>
                 <a:cs typeface="Inter"/>
@@ -2182,7 +2266,7 @@
       </p:sp>
       <p:sp>
         <p:nvSpPr>
-          <p:cNvPr id="3" name="Accent"/>
+          <p:cNvPr id="4" name="Accent"/>
           <p:cNvSpPr/>
           <p:nvPr/>
         </p:nvSpPr>
@@ -2211,7 +2295,7 @@
       </p:sp>
       <p:sp>
         <p:nvSpPr>
-          <p:cNvPr id="4" name="Body"/>
+          <p:cNvPr id="5" name="Body"/>
           <p:cNvSpPr txBox="1"/>
           <p:nvPr/>
         </p:nvSpPr>
@@ -2240,7 +2324,7 @@
             <a:r>
               <a:rPr lang="en-US" sz="1500" b="0" i="0" dirty="0">
                 <a:solidFill>
-                  <a:srgbClr val="3A3A3A"/>
+                  <a:srgbClr val="9A9A9A"/>
                 </a:solidFill>
                 <a:latin typeface="Inter"/>
                 <a:cs typeface="Inter"/>
@@ -2258,7 +2342,7 @@
             <a:r>
               <a:rPr lang="en-US" sz="1500" b="1" i="0" dirty="0">
                 <a:solidFill>
-                  <a:srgbClr val="1F1F1F"/>
+                  <a:srgbClr val="FFFFFF"/>
                 </a:solidFill>
                 <a:latin typeface="Inter"/>
                 <a:cs typeface="Inter"/>
@@ -2286,7 +2370,7 @@
             <a:r>
               <a:rPr lang="en-US" sz="1500" b="0" i="0" dirty="0">
                 <a:solidFill>
-                  <a:srgbClr val="3A3A3A"/>
+                  <a:srgbClr val="9A9A9A"/>
                 </a:solidFill>
                 <a:latin typeface="Inter"/>
                 <a:cs typeface="Inter"/>
@@ -2314,7 +2398,7 @@
             <a:r>
               <a:rPr lang="en-US" sz="1500" b="0" i="0" dirty="0">
                 <a:solidFill>
-                  <a:srgbClr val="3A3A3A"/>
+                  <a:srgbClr val="9A9A9A"/>
                 </a:solidFill>
                 <a:latin typeface="Inter"/>
                 <a:cs typeface="Inter"/>
@@ -2326,7 +2410,7 @@
       </p:sp>
       <p:sp>
         <p:nvSpPr>
-          <p:cNvPr id="5" name="Footer"/>
+          <p:cNvPr id="6" name="Footer"/>
           <p:cNvSpPr txBox="1"/>
           <p:nvPr/>
         </p:nvSpPr>
@@ -2355,7 +2439,7 @@
             <a:r>
               <a:rPr lang="en-US" sz="1000" b="0" i="0" dirty="0">
                 <a:solidFill>
-                  <a:srgbClr val="FBFAF6"/>
+                  <a:srgbClr val="5A5A5A"/>
                 </a:solidFill>
                 <a:latin typeface="Inter"/>
                 <a:cs typeface="Inter"/>
@@ -2376,6 +2460,17 @@
 <file path=ppt/slides/slide6.xml><?xml version="1.0" encoding="utf-8"?>
 <p:sld xmlns:a="http://schemas.openxmlformats.org/drawingml/2006/main" xmlns:r="http://schemas.openxmlformats.org/officeDocument/2006/relationships" xmlns:p="http://schemas.openxmlformats.org/presentationml/2006/main">
   <p:cSld>
+    <p:bg>
+      <p:bgPr>
+        <a:blipFill>
+          <a:blip r:embed="rId2"/>
+          <a:stretch>
+            <a:fillRect/>
+          </a:stretch>
+        </a:blipFill>
+        <a:effectLst/>
+      </p:bgPr>
+    </p:bg>
     <p:spTree>
       <p:nvGrpSpPr>
         <p:cNvPr id="1" name=""/>
@@ -2392,7 +2487,38 @@
       </p:grpSpPr>
       <p:sp>
         <p:nvSpPr>
-          <p:cNvPr id="2" name="Title"/>
+          <p:cNvPr id="2" name="Scrim"/>
+          <p:cNvSpPr/>
+          <p:nvPr/>
+        </p:nvSpPr>
+        <p:spPr>
+          <a:xfrm>
+            <a:off x="0" y="0"/>
+            <a:ext cx="12192000" cy="6858000"/>
+          </a:xfrm>
+          <a:prstGeom prst="rect">
+            <a:avLst/>
+          </a:prstGeom>
+          <a:solidFill>
+            <a:srgbClr val="0B0B0B">
+              <a:alpha val="60000"/>
+            </a:srgbClr>
+          </a:solidFill>
+          <a:ln>
+            <a:noFill/>
+          </a:ln>
+        </p:spPr>
+        <p:txBody>
+          <a:bodyPr/>
+          <a:lstStyle/>
+          <a:p>
+            <a:endParaRPr lang="en-US"/>
+          </a:p>
+        </p:txBody>
+      </p:sp>
+      <p:sp>
+        <p:nvSpPr>
+          <p:cNvPr id="3" name="Title"/>
           <p:cNvSpPr txBox="1"/>
           <p:nvPr/>
         </p:nvSpPr>
@@ -2419,7 +2545,7 @@
             <a:r>
               <a:rPr lang="en-US" sz="2800" b="1" i="0" dirty="0">
                 <a:solidFill>
-                  <a:srgbClr val="1F1F1F"/>
+                  <a:srgbClr val="FFFFFF"/>
                 </a:solidFill>
                 <a:latin typeface="Inter"/>
                 <a:cs typeface="Inter"/>
@@ -2431,7 +2557,7 @@
       </p:sp>
       <p:sp>
         <p:nvSpPr>
-          <p:cNvPr id="3" name="Accent"/>
+          <p:cNvPr id="4" name="Accent"/>
           <p:cNvSpPr/>
           <p:nvPr/>
         </p:nvSpPr>
@@ -2460,7 +2586,7 @@
       </p:sp>
       <p:sp>
         <p:nvSpPr>
-          <p:cNvPr id="4" name="Body"/>
+          <p:cNvPr id="5" name="Body"/>
           <p:cNvSpPr txBox="1"/>
           <p:nvPr/>
         </p:nvSpPr>
@@ -2499,7 +2625,7 @@
             <a:r>
               <a:rPr lang="en-US" sz="1500" b="0" i="0" dirty="0">
                 <a:solidFill>
-                  <a:srgbClr val="3A3A3A"/>
+                  <a:srgbClr val="9A9A9A"/>
                 </a:solidFill>
                 <a:latin typeface="Inter"/>
                 <a:cs typeface="Inter"/>
@@ -2517,7 +2643,7 @@
             <a:r>
               <a:rPr lang="en-US" sz="1500" b="1" i="0" dirty="0">
                 <a:solidFill>
-                  <a:srgbClr val="1F1F1F"/>
+                  <a:srgbClr val="FFFFFF"/>
                 </a:solidFill>
                 <a:latin typeface="Inter"/>
                 <a:cs typeface="Inter"/>
@@ -2535,7 +2661,7 @@
             <a:r>
               <a:rPr lang="en-US" sz="1500" b="0" i="0" dirty="0">
                 <a:solidFill>
-                  <a:srgbClr val="3A3A3A"/>
+                  <a:srgbClr val="9A9A9A"/>
                 </a:solidFill>
                 <a:latin typeface="Inter"/>
                 <a:cs typeface="Inter"/>
@@ -2547,7 +2673,7 @@
       </p:sp>
       <p:sp>
         <p:nvSpPr>
-          <p:cNvPr id="5" name="Footer"/>
+          <p:cNvPr id="6" name="Footer"/>
           <p:cNvSpPr txBox="1"/>
           <p:nvPr/>
         </p:nvSpPr>
@@ -2576,7 +2702,7 @@
             <a:r>
               <a:rPr lang="en-US" sz="1000" b="0" i="0" dirty="0">
                 <a:solidFill>
-                  <a:srgbClr val="FBFAF6"/>
+                  <a:srgbClr val="5A5A5A"/>
                 </a:solidFill>
                 <a:latin typeface="Inter"/>
                 <a:cs typeface="Inter"/>
@@ -2640,7 +2766,7 @@
             <a:r>
               <a:rPr lang="en-US" sz="2800" b="1" i="0" dirty="0">
                 <a:solidFill>
-                  <a:srgbClr val="1F1F1F"/>
+                  <a:srgbClr val="FFFFFF"/>
                 </a:solidFill>
                 <a:latin typeface="Inter"/>
                 <a:cs typeface="Inter"/>
@@ -2712,7 +2838,7 @@
                       <a:r>
                         <a:rPr lang="en-US" sz="1200" b="1" i="0" dirty="0">
                           <a:solidFill>
-                            <a:srgbClr val="1F1F1F"/>
+                            <a:srgbClr val="2A1204"/>
                           </a:solidFill>
                           <a:latin typeface="Inter"/>
                           <a:cs typeface="Inter"/>
@@ -2741,7 +2867,7 @@
                       <a:r>
                         <a:rPr lang="en-US" sz="1200" b="1" i="0" dirty="0">
                           <a:solidFill>
-                            <a:srgbClr val="1F1F1F"/>
+                            <a:srgbClr val="2A1204"/>
                           </a:solidFill>
                           <a:latin typeface="Inter"/>
                           <a:cs typeface="Inter"/>
@@ -2772,7 +2898,7 @@
                       <a:r>
                         <a:rPr lang="en-US" sz="1200" b="0" i="0" dirty="0">
                           <a:solidFill>
-                            <a:srgbClr val="3A3A3A"/>
+                            <a:srgbClr val="9A9A9A"/>
                           </a:solidFill>
                           <a:latin typeface="Inter"/>
                           <a:cs typeface="Inter"/>
@@ -2797,7 +2923,7 @@
                       <a:r>
                         <a:rPr lang="en-US" sz="1200" b="0" i="0" dirty="0">
                           <a:solidFill>
-                            <a:srgbClr val="3A3A3A"/>
+                            <a:srgbClr val="9A9A9A"/>
                           </a:solidFill>
                           <a:latin typeface="Inter"/>
                           <a:cs typeface="Inter"/>
@@ -2824,7 +2950,7 @@
                       <a:r>
                         <a:rPr lang="en-US" sz="1200" b="0" i="0" dirty="0">
                           <a:solidFill>
-                            <a:srgbClr val="3A3A3A"/>
+                            <a:srgbClr val="9A9A9A"/>
                           </a:solidFill>
                           <a:latin typeface="Inter"/>
                           <a:cs typeface="Inter"/>
@@ -2835,7 +2961,7 @@
                   </a:txBody>
                   <a:tcPr marL="91440" marR="91440" marT="45720" marB="45720">
                     <a:solidFill>
-                      <a:srgbClr val="FBFAF6"/>
+                      <a:srgbClr val="161616"/>
                     </a:solidFill>
                   </a:tcPr>
                 </a:tc>
@@ -2853,7 +2979,7 @@
                       <a:r>
                         <a:rPr lang="en-US" sz="1200" b="0" i="0" dirty="0">
                           <a:solidFill>
-                            <a:srgbClr val="3A3A3A"/>
+                            <a:srgbClr val="9A9A9A"/>
                           </a:solidFill>
                           <a:latin typeface="Inter"/>
                           <a:cs typeface="Inter"/>
@@ -2864,7 +2990,7 @@
                   </a:txBody>
                   <a:tcPr marL="91440" marR="91440" marT="45720" marB="45720">
                     <a:solidFill>
-                      <a:srgbClr val="FBFAF6"/>
+                      <a:srgbClr val="161616"/>
                     </a:solidFill>
                   </a:tcPr>
                 </a:tc>
@@ -2884,7 +3010,7 @@
                       <a:r>
                         <a:rPr lang="en-US" sz="1200" b="0" i="0" dirty="0">
                           <a:solidFill>
-                            <a:srgbClr val="3A3A3A"/>
+                            <a:srgbClr val="9A9A9A"/>
                           </a:solidFill>
                           <a:latin typeface="Inter"/>
                           <a:cs typeface="Inter"/>
@@ -2909,7 +3035,7 @@
                       <a:r>
                         <a:rPr lang="en-US" sz="1200" b="0" i="0" dirty="0">
                           <a:solidFill>
-                            <a:srgbClr val="3A3A3A"/>
+                            <a:srgbClr val="9A9A9A"/>
                           </a:solidFill>
                           <a:latin typeface="Inter"/>
                           <a:cs typeface="Inter"/>
@@ -2936,7 +3062,7 @@
                       <a:r>
                         <a:rPr lang="en-US" sz="1200" b="0" i="0" dirty="0">
                           <a:solidFill>
-                            <a:srgbClr val="3A3A3A"/>
+                            <a:srgbClr val="9A9A9A"/>
                           </a:solidFill>
                           <a:latin typeface="Inter"/>
                           <a:cs typeface="Inter"/>
@@ -2947,7 +3073,7 @@
                   </a:txBody>
                   <a:tcPr marL="91440" marR="91440" marT="45720" marB="45720">
                     <a:solidFill>
-                      <a:srgbClr val="FBFAF6"/>
+                      <a:srgbClr val="161616"/>
                     </a:solidFill>
                   </a:tcPr>
                 </a:tc>
@@ -2965,7 +3091,7 @@
                       <a:r>
                         <a:rPr lang="en-US" sz="1200" b="0" i="0" dirty="0">
                           <a:solidFill>
-                            <a:srgbClr val="3A3A3A"/>
+                            <a:srgbClr val="9A9A9A"/>
                           </a:solidFill>
                           <a:latin typeface="Inter"/>
                           <a:cs typeface="Inter"/>
@@ -2976,7 +3102,7 @@
                   </a:txBody>
                   <a:tcPr marL="91440" marR="91440" marT="45720" marB="45720">
                     <a:solidFill>
-                      <a:srgbClr val="FBFAF6"/>
+                      <a:srgbClr val="161616"/>
                     </a:solidFill>
                   </a:tcPr>
                 </a:tc>
@@ -2996,7 +3122,7 @@
                       <a:r>
                         <a:rPr lang="en-US" sz="1200" b="0" i="0" dirty="0">
                           <a:solidFill>
-                            <a:srgbClr val="3A3A3A"/>
+                            <a:srgbClr val="9A9A9A"/>
                           </a:solidFill>
                           <a:latin typeface="Inter"/>
                           <a:cs typeface="Inter"/>
@@ -3021,7 +3147,7 @@
                       <a:r>
                         <a:rPr lang="en-US" sz="1200" b="0" i="0" dirty="0">
                           <a:solidFill>
-                            <a:srgbClr val="3A3A3A"/>
+                            <a:srgbClr val="9A9A9A"/>
                           </a:solidFill>
                           <a:latin typeface="Inter"/>
                           <a:cs typeface="Inter"/>
@@ -3068,7 +3194,7 @@
             <a:r>
               <a:rPr lang="en-US" sz="1500" b="1" i="0" dirty="0">
                 <a:solidFill>
-                  <a:srgbClr val="1F1F1F"/>
+                  <a:srgbClr val="FFFFFF"/>
                 </a:solidFill>
                 <a:latin typeface="Inter"/>
                 <a:cs typeface="Inter"/>
@@ -3086,7 +3212,7 @@
             <a:r>
               <a:rPr lang="en-US" sz="1500" b="0" i="0" dirty="0">
                 <a:solidFill>
-                  <a:srgbClr val="3A3A3A"/>
+                  <a:srgbClr val="9A9A9A"/>
                 </a:solidFill>
                 <a:latin typeface="Inter"/>
                 <a:cs typeface="Inter"/>
@@ -3127,7 +3253,7 @@
             <a:r>
               <a:rPr lang="en-US" sz="1000" b="0" i="0" dirty="0">
                 <a:solidFill>
-                  <a:srgbClr val="FBFAF6"/>
+                  <a:srgbClr val="5A5A5A"/>
                 </a:solidFill>
                 <a:latin typeface="Inter"/>
                 <a:cs typeface="Inter"/>
@@ -3148,6 +3274,17 @@
 <file path=ppt/slides/slide8.xml><?xml version="1.0" encoding="utf-8"?>
 <p:sld xmlns:a="http://schemas.openxmlformats.org/drawingml/2006/main" xmlns:r="http://schemas.openxmlformats.org/officeDocument/2006/relationships" xmlns:p="http://schemas.openxmlformats.org/presentationml/2006/main">
   <p:cSld>
+    <p:bg>
+      <p:bgPr>
+        <a:blipFill>
+          <a:blip r:embed="rId2"/>
+          <a:stretch>
+            <a:fillRect/>
+          </a:stretch>
+        </a:blipFill>
+        <a:effectLst/>
+      </p:bgPr>
+    </p:bg>
     <p:spTree>
       <p:nvGrpSpPr>
         <p:cNvPr id="1" name=""/>
@@ -3164,7 +3301,38 @@
       </p:grpSpPr>
       <p:sp>
         <p:nvSpPr>
-          <p:cNvPr id="2" name="Title"/>
+          <p:cNvPr id="2" name="Scrim"/>
+          <p:cNvSpPr/>
+          <p:nvPr/>
+        </p:nvSpPr>
+        <p:spPr>
+          <a:xfrm>
+            <a:off x="0" y="0"/>
+            <a:ext cx="12192000" cy="6858000"/>
+          </a:xfrm>
+          <a:prstGeom prst="rect">
+            <a:avLst/>
+          </a:prstGeom>
+          <a:solidFill>
+            <a:srgbClr val="0B0B0B">
+              <a:alpha val="60000"/>
+            </a:srgbClr>
+          </a:solidFill>
+          <a:ln>
+            <a:noFill/>
+          </a:ln>
+        </p:spPr>
+        <p:txBody>
+          <a:bodyPr/>
+          <a:lstStyle/>
+          <a:p>
+            <a:endParaRPr lang="en-US"/>
+          </a:p>
+        </p:txBody>
+      </p:sp>
+      <p:sp>
+        <p:nvSpPr>
+          <p:cNvPr id="3" name="Title"/>
           <p:cNvSpPr txBox="1"/>
           <p:nvPr/>
         </p:nvSpPr>
@@ -3191,7 +3359,7 @@
             <a:r>
               <a:rPr lang="en-US" sz="2800" b="1" i="0" dirty="0">
                 <a:solidFill>
-                  <a:srgbClr val="1F1F1F"/>
+                  <a:srgbClr val="FFFFFF"/>
                 </a:solidFill>
                 <a:latin typeface="Inter"/>
                 <a:cs typeface="Inter"/>
@@ -3203,7 +3371,7 @@
       </p:sp>
       <p:sp>
         <p:nvSpPr>
-          <p:cNvPr id="3" name="Accent"/>
+          <p:cNvPr id="4" name="Accent"/>
           <p:cNvSpPr/>
           <p:nvPr/>
         </p:nvSpPr>
@@ -3232,7 +3400,7 @@
       </p:sp>
       <p:sp>
         <p:nvSpPr>
-          <p:cNvPr id="4" name="Body"/>
+          <p:cNvPr id="5" name="Body"/>
           <p:cNvSpPr txBox="1"/>
           <p:nvPr/>
         </p:nvSpPr>
@@ -3261,7 +3429,7 @@
             <a:r>
               <a:rPr lang="en-US" sz="1500" b="0" i="0" dirty="0">
                 <a:solidFill>
-                  <a:srgbClr val="3A3A3A"/>
+                  <a:srgbClr val="9A9A9A"/>
                 </a:solidFill>
                 <a:latin typeface="Inter"/>
                 <a:cs typeface="Inter"/>
@@ -3273,7 +3441,7 @@
       </p:sp>
       <p:sp>
         <p:nvSpPr>
-          <p:cNvPr id="5" name="Footer"/>
+          <p:cNvPr id="6" name="Footer"/>
           <p:cNvSpPr txBox="1"/>
           <p:nvPr/>
         </p:nvSpPr>
@@ -3302,7 +3470,7 @@
             <a:r>
               <a:rPr lang="en-US" sz="1000" b="0" i="0" dirty="0">
                 <a:solidFill>
-                  <a:srgbClr val="FBFAF6"/>
+                  <a:srgbClr val="5A5A5A"/>
                 </a:solidFill>
                 <a:latin typeface="Inter"/>
                 <a:cs typeface="Inter"/>
@@ -3366,7 +3534,7 @@
             <a:r>
               <a:rPr lang="en-US" sz="2800" b="1" i="0" dirty="0">
                 <a:solidFill>
-                  <a:srgbClr val="1F1F1F"/>
+                  <a:srgbClr val="FFFFFF"/>
                 </a:solidFill>
                 <a:latin typeface="Inter"/>
                 <a:cs typeface="Inter"/>
@@ -3440,7 +3608,7 @@
                       <a:r>
                         <a:rPr lang="en-US" sz="1200" b="1" i="0" dirty="0">
                           <a:solidFill>
-                            <a:srgbClr val="1F1F1F"/>
+                            <a:srgbClr val="2A1204"/>
                           </a:solidFill>
                           <a:latin typeface="Inter"/>
                           <a:cs typeface="Inter"/>
@@ -3469,7 +3637,7 @@
                       <a:r>
                         <a:rPr lang="en-US" sz="1200" b="1" i="0" dirty="0">
                           <a:solidFill>
-                            <a:srgbClr val="1F1F1F"/>
+                            <a:srgbClr val="2A1204"/>
                           </a:solidFill>
                           <a:latin typeface="Inter"/>
                           <a:cs typeface="Inter"/>
@@ -3498,7 +3666,7 @@
                       <a:r>
                         <a:rPr lang="en-US" sz="1200" b="1" i="0" dirty="0">
                           <a:solidFill>
-                            <a:srgbClr val="1F1F1F"/>
+                            <a:srgbClr val="2A1204"/>
                           </a:solidFill>
                           <a:latin typeface="Inter"/>
                           <a:cs typeface="Inter"/>
@@ -3527,7 +3695,7 @@
                       <a:r>
                         <a:rPr lang="en-US" sz="1200" b="1" i="0" dirty="0">
                           <a:solidFill>
-                            <a:srgbClr val="1F1F1F"/>
+                            <a:srgbClr val="2A1204"/>
                           </a:solidFill>
                           <a:latin typeface="Inter"/>
                           <a:cs typeface="Inter"/>
@@ -3558,7 +3726,7 @@
                       <a:r>
                         <a:rPr lang="en-US" sz="1200" b="0" i="0" dirty="0">
                           <a:solidFill>
-                            <a:srgbClr val="3A3A3A"/>
+                            <a:srgbClr val="9A9A9A"/>
                           </a:solidFill>
                           <a:latin typeface="Inter"/>
                           <a:cs typeface="Inter"/>
@@ -3583,7 +3751,7 @@
                       <a:r>
                         <a:rPr lang="en-US" sz="1200" b="0" i="0" dirty="0">
                           <a:solidFill>
-                            <a:srgbClr val="3A3A3A"/>
+                            <a:srgbClr val="9A9A9A"/>
                           </a:solidFill>
                           <a:latin typeface="Inter"/>
                           <a:cs typeface="Inter"/>
@@ -3608,7 +3776,7 @@
                       <a:r>
                         <a:rPr lang="en-US" sz="1200" b="0" i="0" dirty="0">
                           <a:solidFill>
-                            <a:srgbClr val="3A3A3A"/>
+                            <a:srgbClr val="9A9A9A"/>
                           </a:solidFill>
                           <a:latin typeface="Inter"/>
                           <a:cs typeface="Inter"/>
@@ -3633,7 +3801,7 @@
                       <a:r>
                         <a:rPr lang="en-US" sz="1200" b="0" i="0" dirty="0">
                           <a:solidFill>
-                            <a:srgbClr val="3A3A3A"/>
+                            <a:srgbClr val="9A9A9A"/>
                           </a:solidFill>
                           <a:latin typeface="Inter"/>
                           <a:cs typeface="Inter"/>
@@ -3660,7 +3828,7 @@
                       <a:r>
                         <a:rPr lang="en-US" sz="1200" b="0" i="0" dirty="0">
                           <a:solidFill>
-                            <a:srgbClr val="3A3A3A"/>
+                            <a:srgbClr val="9A9A9A"/>
                           </a:solidFill>
                           <a:latin typeface="Inter"/>
                           <a:cs typeface="Inter"/>
@@ -3671,7 +3839,7 @@
                   </a:txBody>
                   <a:tcPr marL="91440" marR="91440" marT="45720" marB="45720">
                     <a:solidFill>
-                      <a:srgbClr val="FBFAF6"/>
+                      <a:srgbClr val="161616"/>
                     </a:solidFill>
                   </a:tcPr>
                 </a:tc>
@@ -3689,7 +3857,7 @@
                       <a:r>
                         <a:rPr lang="en-US" sz="1200" b="0" i="0" dirty="0">
                           <a:solidFill>
-                            <a:srgbClr val="3A3A3A"/>
+                            <a:srgbClr val="9A9A9A"/>
                           </a:solidFill>
                           <a:latin typeface="Inter"/>
                           <a:cs typeface="Inter"/>
@@ -3700,7 +3868,7 @@
                   </a:txBody>
                   <a:tcPr marL="91440" marR="91440" marT="45720" marB="45720">
                     <a:solidFill>
-                      <a:srgbClr val="FBFAF6"/>
+                      <a:srgbClr val="161616"/>
                     </a:solidFill>
                   </a:tcPr>
                 </a:tc>
@@ -3718,7 +3886,7 @@
                       <a:r>
                         <a:rPr lang="en-US" sz="1200" b="0" i="0" dirty="0">
                           <a:solidFill>
-                            <a:srgbClr val="3A3A3A"/>
+                            <a:srgbClr val="9A9A9A"/>
                           </a:solidFill>
                           <a:latin typeface="Inter"/>
                           <a:cs typeface="Inter"/>
@@ -3729,7 +3897,7 @@
                   </a:txBody>
                   <a:tcPr marL="91440" marR="91440" marT="45720" marB="45720">
                     <a:solidFill>
-                      <a:srgbClr val="FBFAF6"/>
+                      <a:srgbClr val="161616"/>
                     </a:solidFill>
                   </a:tcPr>
                 </a:tc>
@@ -3747,7 +3915,7 @@
                       <a:r>
                         <a:rPr lang="en-US" sz="1200" b="0" i="0" dirty="0">
                           <a:solidFill>
-                            <a:srgbClr val="3A3A3A"/>
+                            <a:srgbClr val="9A9A9A"/>
                           </a:solidFill>
                           <a:latin typeface="Inter"/>
                           <a:cs typeface="Inter"/>
@@ -3758,7 +3926,7 @@
                   </a:txBody>
                   <a:tcPr marL="91440" marR="91440" marT="45720" marB="45720">
                     <a:solidFill>
-                      <a:srgbClr val="FBFAF6"/>
+                      <a:srgbClr val="161616"/>
                     </a:solidFill>
                   </a:tcPr>
                 </a:tc>
@@ -3778,7 +3946,7 @@
                       <a:r>
                         <a:rPr lang="en-US" sz="1200" b="0" i="0" dirty="0">
                           <a:solidFill>
-                            <a:srgbClr val="3A3A3A"/>
+                            <a:srgbClr val="9A9A9A"/>
                           </a:solidFill>
                           <a:latin typeface="Inter"/>
                           <a:cs typeface="Inter"/>
@@ -3803,7 +3971,7 @@
                       <a:r>
                         <a:rPr lang="en-US" sz="1200" b="0" i="0" dirty="0">
                           <a:solidFill>
-                            <a:srgbClr val="3A3A3A"/>
+                            <a:srgbClr val="9A9A9A"/>
                           </a:solidFill>
                           <a:latin typeface="Inter"/>
                           <a:cs typeface="Inter"/>
@@ -3828,7 +3996,7 @@
                       <a:r>
                         <a:rPr lang="en-US" sz="1200" b="0" i="0" dirty="0">
                           <a:solidFill>
-                            <a:srgbClr val="3A3A3A"/>
+                            <a:srgbClr val="9A9A9A"/>
                           </a:solidFill>
                           <a:latin typeface="Inter"/>
                           <a:cs typeface="Inter"/>
@@ -3853,7 +4021,7 @@
                       <a:r>
                         <a:rPr lang="en-US" sz="1200" b="0" i="0" dirty="0">
                           <a:solidFill>
-                            <a:srgbClr val="3A3A3A"/>
+                            <a:srgbClr val="9A9A9A"/>
                           </a:solidFill>
                           <a:latin typeface="Inter"/>
                           <a:cs typeface="Inter"/>
@@ -3910,7 +4078,7 @@
             <a:r>
               <a:rPr lang="en-US" sz="1500" b="0" i="0" dirty="0">
                 <a:solidFill>
-                  <a:srgbClr val="3A3A3A"/>
+                  <a:srgbClr val="9A9A9A"/>
                 </a:solidFill>
                 <a:latin typeface="Inter"/>
                 <a:cs typeface="Inter"/>
@@ -3928,7 +4096,7 @@
             <a:r>
               <a:rPr lang="en-US" sz="1500" b="0" i="1" dirty="0">
                 <a:solidFill>
-                  <a:srgbClr val="FBFAF6"/>
+                  <a:srgbClr val="5A5A5A"/>
                 </a:solidFill>
                 <a:latin typeface="Inter"/>
                 <a:cs typeface="Inter"/>
@@ -3946,7 +4114,7 @@
             <a:r>
               <a:rPr lang="en-US" sz="1500" b="0" i="1" dirty="0">
                 <a:solidFill>
-                  <a:srgbClr val="FBFAF6"/>
+                  <a:srgbClr val="5A5A5A"/>
                 </a:solidFill>
                 <a:latin typeface="Inter"/>
                 <a:cs typeface="Inter"/>
@@ -3974,7 +4142,7 @@
             <a:r>
               <a:rPr lang="en-US" sz="1500" b="0" i="0" dirty="0">
                 <a:solidFill>
-                  <a:srgbClr val="3A3A3A"/>
+                  <a:srgbClr val="9A9A9A"/>
                 </a:solidFill>
                 <a:latin typeface="Inter"/>
                 <a:cs typeface="Inter"/>
@@ -3992,7 +4160,7 @@
             <a:r>
               <a:rPr lang="en-US" sz="1500" b="0" i="1" dirty="0">
                 <a:solidFill>
-                  <a:srgbClr val="FBFAF6"/>
+                  <a:srgbClr val="5A5A5A"/>
                 </a:solidFill>
                 <a:latin typeface="Inter"/>
                 <a:cs typeface="Inter"/>
@@ -4033,7 +4201,7 @@
             <a:r>
               <a:rPr lang="en-US" sz="1000" b="0" i="0" dirty="0">
                 <a:solidFill>
-                  <a:srgbClr val="FBFAF6"/>
+                  <a:srgbClr val="5A5A5A"/>
                 </a:solidFill>
                 <a:latin typeface="Inter"/>
                 <a:cs typeface="Inter"/>
@@ -4056,16 +4224,16 @@
   <a:themeElements>
     <a:clrScheme name="StartupOS">
       <a:dk1>
-        <a:srgbClr val="1F1F1F"/>
+        <a:srgbClr val="FFFFFF"/>
       </a:dk1>
       <a:lt1>
-        <a:srgbClr val="F3F0E7"/>
+        <a:srgbClr val="0B0B0B"/>
       </a:lt1>
       <a:dk2>
-        <a:srgbClr val="3A3A3A"/>
+        <a:srgbClr val="9A9A9A"/>
       </a:dk2>
       <a:lt2>
-        <a:srgbClr val="FBFAF6"/>
+        <a:srgbClr val="161616"/>
       </a:lt2>
       <a:accent1>
         <a:srgbClr val="FF6600"/>
@@ -4089,7 +4257,7 @@
         <a:srgbClr val="FF6600"/>
       </a:hlink>
       <a:folHlink>
-        <a:srgbClr val="FBFAF6"/>
+        <a:srgbClr val="5A5A5A"/>
       </a:folHlink>
     </a:clrScheme>
     <a:fontScheme name="StartupOS">

</xml_diff>

<commit_message>
docs(marketing): fix pitch deck cover and screenshot-slide layout
Cover now leads with the Supacharge wordmark (Inter SemiBold, 64pt) with the tagline and a subordinate 'A product of ROKCT INTELLIGENCE (PTY) LTD' line; the registered-name boilerplate that the certificate parser leaked into the title, footers and corporate-standing slide is corrected at the compliance-overrides layer. Footers on every slide now lead with Supacharge. On the four app-screenshot slides the text column is narrowed and the phone composite constrained to the right column so text never sits over the screens. Content and figures unchanged.
</commit_message>
<xml_diff>
--- a/marketing/pitch/supacharge-pitch-deck.pptx
+++ b/marketing/pitch/supacharge-pitch-deck.pptx
@@ -155,14 +155,14 @@
               <a:buNone/>
             </a:pPr>
             <a:r>
-              <a:rPr lang="en-US" sz="4000" b="1" i="0" dirty="0">
+              <a:rPr lang="en-US" sz="6400" b="1" i="0" dirty="0">
                 <a:solidFill>
                   <a:srgbClr val="FFFFFF"/>
                 </a:solidFill>
                 <a:latin typeface="Inter"/>
                 <a:cs typeface="Inter"/>
               </a:rPr>
-              <a:t>ROKCT INTELLIGENCE (PTY) LTD Enterprise shortened name NOT APPLICABLE Enterprise translated name NOT APPLICABLE</a:t>
+              <a:t>Supacharge</a:t>
             </a:r>
           </a:p>
         </p:txBody>
@@ -224,6 +224,22 @@
               <a:t>EdTech — high-school (FET phase) live tutoring · South Africa (Musina, Limpopo) · founded Supacharge operates under ROKCT INTELLIGENCE (PTY) LTD, registered 25 November 2025 (CIPC 2025/919921/07); source: CIPC Business Registration Certificate in Compliance/ROKCT/.</a:t>
             </a:r>
           </a:p>
+          <a:p>
+            <a:pPr>
+              <a:spcBef>
+                <a:spcPts val="1000"/>
+              </a:spcBef>
+            </a:pPr>
+            <a:r>
+              <a:rPr sz="1200">
+                <a:solidFill>
+                  <a:srgbClr val="5A5A5A"/>
+                </a:solidFill>
+                <a:latin typeface="Inter"/>
+              </a:rPr>
+              <a:t>A product of ROKCT INTELLIGENCE (PTY) LTD</a:t>
+            </a:r>
+          </a:p>
         </p:txBody>
       </p:sp>
       <p:sp>
@@ -262,7 +278,7 @@
                 <a:latin typeface="Inter"/>
                 <a:cs typeface="Inter"/>
               </a:rPr>
-              <a:t>ROKCT INTELLIGENCE (PTY) LTD Enterprise shortened name NOT APPLICABLE Enterprise translated name NOT APPLICABLE  ·  1 / 12</a:t>
+              <a:t>Supacharge  ·  1 / 12</a:t>
             </a:r>
           </a:p>
         </p:txBody>
@@ -605,7 +621,7 @@
                 <a:latin typeface="Inter"/>
                 <a:cs typeface="Inter"/>
               </a:rPr>
-              <a:t>ROKCT INTELLIGENCE (PTY) LTD Enterprise shortened name NOT APPLICABLE Enterprise translated name NOT APPLICABLE  ·  10 / 12</a:t>
+              <a:t>Supacharge  ·  10 / 12</a:t>
             </a:r>
           </a:p>
         </p:txBody>
@@ -854,7 +870,7 @@
                 <a:latin typeface="Inter"/>
                 <a:cs typeface="Inter"/>
               </a:rPr>
-              <a:t>ROKCT INTELLIGENCE (PTY) LTD Enterprise shortened name NOT APPLICABLE Enterprise translated name NOT APPLICABLE  ·  11 / 12</a:t>
+              <a:t>Supacharge  ·  11 / 12</a:t>
             </a:r>
           </a:p>
         </p:txBody>
@@ -998,7 +1014,7 @@
                 <a:latin typeface="Inter"/>
                 <a:cs typeface="Inter"/>
               </a:rPr>
-              <a:t>Registered legal name: ROKCT INTELLIGENCE (PTY) LTD Enterprise shortened name NOT APPLICABLE Enterprise translated name NOT APPLICABLE</a:t>
+              <a:t>Registered legal name: ROKCT INTELLIGENCE (PTY) LTD</a:t>
             </a:r>
           </a:p>
           <a:p>
@@ -1177,7 +1193,7 @@
                 <a:latin typeface="Inter"/>
                 <a:cs typeface="Inter"/>
               </a:rPr>
-              <a:t>ROKCT INTELLIGENCE (PTY) LTD Enterprise shortened name NOT APPLICABLE Enterprise translated name NOT APPLICABLE  ·  12 / 12</a:t>
+              <a:t>Supacharge  ·  12 / 12</a:t>
             </a:r>
           </a:p>
         </p:txBody>
@@ -1352,7 +1368,7 @@
                 <a:latin typeface="Inter"/>
                 <a:cs typeface="Inter"/>
               </a:rPr>
-              <a:t>ROKCT INTELLIGENCE (PTY) LTD Enterprise shortened name NOT APPLICABLE Enterprise translated name NOT APPLICABLE  ·  2 / 12</a:t>
+              <a:t>Supacharge  ·  2 / 12</a:t>
             </a:r>
           </a:p>
         </p:txBody>
@@ -1433,7 +1449,7 @@
         <p:spPr>
           <a:xfrm>
             <a:off x="685800" y="396240"/>
-            <a:ext cx="10820400" cy="822960"/>
+            <a:ext cx="7498079" cy="822960"/>
           </a:xfrm>
           <a:prstGeom prst="rect">
             <a:avLst/>
@@ -1501,7 +1517,7 @@
         <p:spPr>
           <a:xfrm>
             <a:off x="685800" y="1481328"/>
-            <a:ext cx="10820400" cy="4684392"/>
+            <a:ext cx="7498079" cy="4684392"/>
           </a:xfrm>
           <a:prstGeom prst="rect">
             <a:avLst/>
@@ -1605,7 +1621,7 @@
                 <a:latin typeface="Inter"/>
                 <a:cs typeface="Inter"/>
               </a:rPr>
-              <a:t>ROKCT INTELLIGENCE (PTY) LTD Enterprise shortened name NOT APPLICABLE Enterprise translated name NOT APPLICABLE  ·  3 / 12</a:t>
+              <a:t>Supacharge  ·  3 / 12</a:t>
             </a:r>
           </a:p>
         </p:txBody>
@@ -2153,7 +2169,7 @@
                 <a:latin typeface="Inter"/>
                 <a:cs typeface="Inter"/>
               </a:rPr>
-              <a:t>ROKCT INTELLIGENCE (PTY) LTD Enterprise shortened name NOT APPLICABLE Enterprise translated name NOT APPLICABLE  ·  4 / 12</a:t>
+              <a:t>Supacharge  ·  4 / 12</a:t>
             </a:r>
           </a:p>
         </p:txBody>
@@ -2234,7 +2250,7 @@
         <p:spPr>
           <a:xfrm>
             <a:off x="685800" y="396240"/>
-            <a:ext cx="10820400" cy="822960"/>
+            <a:ext cx="7498079" cy="822960"/>
           </a:xfrm>
           <a:prstGeom prst="rect">
             <a:avLst/>
@@ -2302,7 +2318,7 @@
         <p:spPr>
           <a:xfrm>
             <a:off x="685800" y="1481328"/>
-            <a:ext cx="10820400" cy="4684392"/>
+            <a:ext cx="7498079" cy="4684392"/>
           </a:xfrm>
           <a:prstGeom prst="rect">
             <a:avLst/>
@@ -2444,7 +2460,7 @@
                 <a:latin typeface="Inter"/>
                 <a:cs typeface="Inter"/>
               </a:rPr>
-              <a:t>ROKCT INTELLIGENCE (PTY) LTD Enterprise shortened name NOT APPLICABLE Enterprise translated name NOT APPLICABLE  ·  5 / 12</a:t>
+              <a:t>Supacharge  ·  5 / 12</a:t>
             </a:r>
           </a:p>
         </p:txBody>
@@ -2525,7 +2541,7 @@
         <p:spPr>
           <a:xfrm>
             <a:off x="685800" y="396240"/>
-            <a:ext cx="10820400" cy="822960"/>
+            <a:ext cx="7498079" cy="822960"/>
           </a:xfrm>
           <a:prstGeom prst="rect">
             <a:avLst/>
@@ -2593,7 +2609,7 @@
         <p:spPr>
           <a:xfrm>
             <a:off x="685800" y="1481328"/>
-            <a:ext cx="10820400" cy="4684392"/>
+            <a:ext cx="7498079" cy="4684392"/>
           </a:xfrm>
           <a:prstGeom prst="rect">
             <a:avLst/>
@@ -2707,7 +2723,7 @@
                 <a:latin typeface="Inter"/>
                 <a:cs typeface="Inter"/>
               </a:rPr>
-              <a:t>ROKCT INTELLIGENCE (PTY) LTD Enterprise shortened name NOT APPLICABLE Enterprise translated name NOT APPLICABLE  ·  6 / 12</a:t>
+              <a:t>Supacharge  ·  6 / 12</a:t>
             </a:r>
           </a:p>
         </p:txBody>
@@ -3258,7 +3274,7 @@
                 <a:latin typeface="Inter"/>
                 <a:cs typeface="Inter"/>
               </a:rPr>
-              <a:t>ROKCT INTELLIGENCE (PTY) LTD Enterprise shortened name NOT APPLICABLE Enterprise translated name NOT APPLICABLE  ·  7 / 12</a:t>
+              <a:t>Supacharge  ·  7 / 12</a:t>
             </a:r>
           </a:p>
         </p:txBody>
@@ -3339,7 +3355,7 @@
         <p:spPr>
           <a:xfrm>
             <a:off x="685800" y="396240"/>
-            <a:ext cx="10820400" cy="822960"/>
+            <a:ext cx="7498079" cy="822960"/>
           </a:xfrm>
           <a:prstGeom prst="rect">
             <a:avLst/>
@@ -3407,7 +3423,7 @@
         <p:spPr>
           <a:xfrm>
             <a:off x="685800" y="1481328"/>
-            <a:ext cx="10820400" cy="4684392"/>
+            <a:ext cx="7498079" cy="4684392"/>
           </a:xfrm>
           <a:prstGeom prst="rect">
             <a:avLst/>
@@ -3475,7 +3491,7 @@
                 <a:latin typeface="Inter"/>
                 <a:cs typeface="Inter"/>
               </a:rPr>
-              <a:t>ROKCT INTELLIGENCE (PTY) LTD Enterprise shortened name NOT APPLICABLE Enterprise translated name NOT APPLICABLE  ·  8 / 12</a:t>
+              <a:t>Supacharge  ·  8 / 12</a:t>
             </a:r>
           </a:p>
         </p:txBody>
@@ -4206,7 +4222,7 @@
                 <a:latin typeface="Inter"/>
                 <a:cs typeface="Inter"/>
               </a:rPr>
-              <a:t>ROKCT INTELLIGENCE (PTY) LTD Enterprise shortened name NOT APPLICABLE Enterprise translated name NOT APPLICABLE  ·  9 / 12</a:t>
+              <a:t>Supacharge  ·  9 / 12</a:t>
             </a:r>
           </a:p>
         </p:txBody>

</xml_diff>